<commit_message>
fix(ppt): enforce quality gates and stabilize adaptive release 1.2.1
</commit_message>
<xml_diff>
--- a/skills/editable-research-ppt/examples/fill-comparison.pptx
+++ b/skills/editable-research-ppt/examples/fill-comparison.pptx
@@ -16989,7 +16989,7 @@
           <a:solidFill>
             <a:srgbClr val="FFFFFF"/>
           </a:solidFill>
-          <a:ln w="11430">
+          <a:ln w="11430" cap="rnd">
             <a:solidFill>
               <a:srgbClr val="1359A0"/>
             </a:solidFill>
@@ -17043,7 +17043,7 @@
           <a:solidFill>
             <a:srgbClr val="FFFFFF"/>
           </a:solidFill>
-          <a:ln w="20002">
+          <a:ln w="20002" cap="rnd">
             <a:solidFill>
               <a:srgbClr val="FFFFFF"/>
             </a:solidFill>
@@ -17078,7 +17078,7 @@
           <a:solidFill>
             <a:srgbClr val="FFFFFF"/>
           </a:solidFill>
-          <a:ln w="20002">
+          <a:ln w="20002" cap="rnd">
             <a:solidFill>
               <a:srgbClr val="FFFFFF"/>
             </a:solidFill>
@@ -17111,7 +17111,7 @@
           <a:solidFill>
             <a:srgbClr val="1359A0"/>
           </a:solidFill>
-          <a:ln w="20002">
+          <a:ln w="20002" cap="rnd">
             <a:solidFill>
               <a:srgbClr val="1359A0"/>
             </a:solidFill>
@@ -17144,7 +17144,7 @@
           <a:solidFill>
             <a:srgbClr val="1359A0"/>
           </a:solidFill>
-          <a:ln w="20002">
+          <a:ln w="20002" cap="rnd">
             <a:solidFill>
               <a:srgbClr val="1359A0"/>
             </a:solidFill>
@@ -17499,7 +17499,7 @@
           <a:solidFill>
             <a:srgbClr val="1359A0"/>
           </a:solidFill>
-          <a:ln w="20002">
+          <a:ln w="20002" cap="rnd">
             <a:solidFill>
               <a:srgbClr val="1359A0"/>
             </a:solidFill>
@@ -17534,7 +17534,7 @@
           <a:solidFill>
             <a:srgbClr val="1359A0"/>
           </a:solidFill>
-          <a:ln w="20002">
+          <a:ln w="20002" cap="rnd">
             <a:solidFill>
               <a:srgbClr val="1359A0"/>
             </a:solidFill>
@@ -17567,7 +17567,7 @@
           <a:solidFill>
             <a:srgbClr val="FFFFFF"/>
           </a:solidFill>
-          <a:ln w="20002">
+          <a:ln w="20002" cap="rnd">
             <a:solidFill>
               <a:srgbClr val="FFFFFF"/>
             </a:solidFill>
@@ -17600,7 +17600,7 @@
           <a:solidFill>
             <a:srgbClr val="FFFFFF"/>
           </a:solidFill>
-          <a:ln w="20002">
+          <a:ln w="20002" cap="rnd">
             <a:solidFill>
               <a:srgbClr val="FFFFFF"/>
             </a:solidFill>
@@ -17640,7 +17640,7 @@
             </a:pathLst>
           </a:custGeom>
           <a:noFill/>
-          <a:ln w="20002">
+          <a:ln w="20002" cap="rnd">
             <a:solidFill>
               <a:srgbClr val="1359A0"/>
             </a:solidFill>
@@ -17673,7 +17673,7 @@
           <a:solidFill>
             <a:srgbClr val="1359A0"/>
           </a:solidFill>
-          <a:ln w="20002">
+          <a:ln w="20002" cap="rnd">
             <a:solidFill>
               <a:srgbClr val="1359A0"/>
             </a:solidFill>
@@ -17706,7 +17706,7 @@
           <a:solidFill>
             <a:srgbClr val="1359A0"/>
           </a:solidFill>
-          <a:ln w="20002">
+          <a:ln w="20002" cap="rnd">
             <a:solidFill>
               <a:srgbClr val="1359A0"/>
             </a:solidFill>
@@ -17746,7 +17746,7 @@
             </a:pathLst>
           </a:custGeom>
           <a:noFill/>
-          <a:ln w="20002">
+          <a:ln w="20002" cap="rnd">
             <a:solidFill>
               <a:srgbClr val="1359A0"/>
             </a:solidFill>
@@ -17786,7 +17786,7 @@
             </a:pathLst>
           </a:custGeom>
           <a:noFill/>
-          <a:ln w="20002">
+          <a:ln w="20002" cap="rnd">
             <a:solidFill>
               <a:srgbClr val="1359A0"/>
             </a:solidFill>
@@ -17847,7 +17847,7 @@
           <a:solidFill>
             <a:srgbClr val="1359A0"/>
           </a:solidFill>
-          <a:ln w="20002">
+          <a:ln w="20002" cap="rnd">
             <a:solidFill>
               <a:srgbClr val="1359A0"/>
             </a:solidFill>
@@ -17887,7 +17887,7 @@
             </a:pathLst>
           </a:custGeom>
           <a:noFill/>
-          <a:ln w="20002">
+          <a:ln w="20002" cap="rnd">
             <a:solidFill>
               <a:srgbClr val="FFFFFF"/>
             </a:solidFill>
@@ -17927,7 +17927,7 @@
             </a:pathLst>
           </a:custGeom>
           <a:noFill/>
-          <a:ln w="20002">
+          <a:ln w="20002" cap="rnd">
             <a:solidFill>
               <a:srgbClr val="FFFFFF"/>
             </a:solidFill>
@@ -17960,7 +17960,7 @@
           <a:solidFill>
             <a:srgbClr val="FFFFFF"/>
           </a:solidFill>
-          <a:ln w="20002">
+          <a:ln w="20002" cap="rnd">
             <a:solidFill>
               <a:srgbClr val="FFFFFF"/>
             </a:solidFill>
@@ -17995,7 +17995,7 @@
           <a:solidFill>
             <a:srgbClr val="FFFFFF"/>
           </a:solidFill>
-          <a:ln w="11430">
+          <a:ln w="11430" cap="rnd">
             <a:solidFill>
               <a:srgbClr val="1359A0"/>
             </a:solidFill>
@@ -18054,7 +18054,7 @@
             </a:pathLst>
           </a:custGeom>
           <a:noFill/>
-          <a:ln w="20002">
+          <a:ln w="20002" cap="rnd">
             <a:solidFill>
               <a:srgbClr val="FFFFFF"/>
             </a:solidFill>
@@ -18087,7 +18087,7 @@
           <a:solidFill>
             <a:srgbClr val="FFFFFF"/>
           </a:solidFill>
-          <a:ln w="20002">
+          <a:ln w="20002" cap="rnd">
             <a:solidFill>
               <a:srgbClr val="FFFFFF"/>
             </a:solidFill>
@@ -18475,7 +18475,7 @@
           <a:solidFill>
             <a:srgbClr val="FFFFFF"/>
           </a:solidFill>
-          <a:ln w="11430">
+          <a:ln w="11430" cap="rnd">
             <a:solidFill>
               <a:srgbClr val="1359A0"/>
             </a:solidFill>
@@ -18555,7 +18555,7 @@
           <a:solidFill>
             <a:srgbClr val="FFFFFF"/>
           </a:solidFill>
-          <a:ln w="20002">
+          <a:ln w="20002" cap="rnd">
             <a:solidFill>
               <a:srgbClr val="FFFFFF"/>
             </a:solidFill>
@@ -18595,7 +18595,7 @@
             </a:pathLst>
           </a:custGeom>
           <a:noFill/>
-          <a:ln w="20002">
+          <a:ln w="20002" cap="rnd">
             <a:solidFill>
               <a:srgbClr val="1359A0"/>
             </a:solidFill>
@@ -18635,7 +18635,7 @@
             </a:pathLst>
           </a:custGeom>
           <a:noFill/>
-          <a:ln w="20002">
+          <a:ln w="20002" cap="rnd">
             <a:solidFill>
               <a:srgbClr val="1359A0"/>
             </a:solidFill>
@@ -18668,7 +18668,7 @@
           <a:solidFill>
             <a:srgbClr val="1359A0"/>
           </a:solidFill>
-          <a:ln w="20002">
+          <a:ln w="20002" cap="rnd">
             <a:solidFill>
               <a:srgbClr val="1359A0"/>
             </a:solidFill>
@@ -19037,7 +19037,7 @@
           <a:solidFill>
             <a:srgbClr val="1359A0"/>
           </a:solidFill>
-          <a:ln w="12382">
+          <a:ln w="12382" cap="rnd">
             <a:solidFill>
               <a:srgbClr val="FFFFFF"/>
             </a:solidFill>
@@ -19086,7 +19086,7 @@
           <a:solidFill>
             <a:srgbClr val="1359A0"/>
           </a:solidFill>
-          <a:ln w="12382">
+          <a:ln w="12382" cap="rnd">
             <a:solidFill>
               <a:srgbClr val="FFFFFF"/>
             </a:solidFill>
@@ -19135,7 +19135,7 @@
           <a:solidFill>
             <a:srgbClr val="1359A0"/>
           </a:solidFill>
-          <a:ln w="12382">
+          <a:ln w="12382" cap="rnd">
             <a:solidFill>
               <a:srgbClr val="FFFFFF"/>
             </a:solidFill>
@@ -19170,7 +19170,7 @@
           <a:solidFill>
             <a:srgbClr val="1359A0"/>
           </a:solidFill>
-          <a:ln w="14288">
+          <a:ln w="14288" cap="rnd">
             <a:solidFill>
               <a:srgbClr val="1359A0"/>
             </a:solidFill>
@@ -19203,7 +19203,7 @@
           <a:solidFill>
             <a:srgbClr val="FFFFFF"/>
           </a:solidFill>
-          <a:ln w="20002">
+          <a:ln w="20002" cap="rnd">
             <a:solidFill>
               <a:srgbClr val="FFFFFF"/>
             </a:solidFill>
@@ -19243,7 +19243,7 @@
             </a:pathLst>
           </a:custGeom>
           <a:noFill/>
-          <a:ln w="20002">
+          <a:ln w="20002" cap="rnd">
             <a:solidFill>
               <a:srgbClr val="1359A0"/>
             </a:solidFill>
@@ -19283,7 +19283,7 @@
             </a:pathLst>
           </a:custGeom>
           <a:noFill/>
-          <a:ln w="20002">
+          <a:ln w="20002" cap="rnd">
             <a:solidFill>
               <a:srgbClr val="1359A0"/>
             </a:solidFill>
@@ -19480,7 +19480,7 @@
           <a:solidFill>
             <a:srgbClr val="1359A0"/>
           </a:solidFill>
-          <a:ln w="14288">
+          <a:ln w="14288" cap="rnd">
             <a:solidFill>
               <a:srgbClr val="1359A0"/>
             </a:solidFill>
@@ -19515,7 +19515,7 @@
           <a:solidFill>
             <a:srgbClr val="FFFFFF"/>
           </a:solidFill>
-          <a:ln w="20002">
+          <a:ln w="20002" cap="rnd">
             <a:solidFill>
               <a:srgbClr val="FFFFFF"/>
             </a:solidFill>
@@ -19555,7 +19555,7 @@
             </a:pathLst>
           </a:custGeom>
           <a:noFill/>
-          <a:ln w="20002">
+          <a:ln w="20002" cap="rnd">
             <a:solidFill>
               <a:srgbClr val="1359A0"/>
             </a:solidFill>
@@ -19595,7 +19595,7 @@
             </a:pathLst>
           </a:custGeom>
           <a:noFill/>
-          <a:ln w="20002">
+          <a:ln w="20002" cap="rnd">
             <a:solidFill>
               <a:srgbClr val="FFFFFF"/>
             </a:solidFill>
@@ -19635,7 +19635,7 @@
             </a:pathLst>
           </a:custGeom>
           <a:noFill/>
-          <a:ln w="20002">
+          <a:ln w="20002" cap="rnd">
             <a:solidFill>
               <a:srgbClr val="FFFFFF"/>
             </a:solidFill>
@@ -19668,7 +19668,7 @@
           <a:solidFill>
             <a:srgbClr val="1359A0"/>
           </a:solidFill>
-          <a:ln w="20002">
+          <a:ln w="20002" cap="rnd">
             <a:solidFill>
               <a:srgbClr val="1359A0"/>
             </a:solidFill>
@@ -19701,7 +19701,7 @@
           <a:solidFill>
             <a:srgbClr val="1359A0"/>
           </a:solidFill>
-          <a:ln w="20002">
+          <a:ln w="20002" cap="rnd">
             <a:solidFill>
               <a:srgbClr val="1359A0"/>
             </a:solidFill>
@@ -19734,7 +19734,7 @@
           <a:solidFill>
             <a:srgbClr val="1359A0"/>
           </a:solidFill>
-          <a:ln w="20002">
+          <a:ln w="20002" cap="rnd">
             <a:solidFill>
               <a:srgbClr val="1359A0"/>
             </a:solidFill>
@@ -19767,7 +19767,7 @@
           <a:solidFill>
             <a:srgbClr val="1359A0"/>
           </a:solidFill>
-          <a:ln w="20002">
+          <a:ln w="20002" cap="rnd">
             <a:solidFill>
               <a:srgbClr val="1359A0"/>
             </a:solidFill>
@@ -19800,7 +19800,7 @@
           <a:solidFill>
             <a:srgbClr val="1359A0"/>
           </a:solidFill>
-          <a:ln w="20002">
+          <a:ln w="20002" cap="rnd">
             <a:solidFill>
               <a:srgbClr val="1359A0"/>
             </a:solidFill>
@@ -19833,7 +19833,7 @@
           <a:solidFill>
             <a:srgbClr val="1359A0"/>
           </a:solidFill>
-          <a:ln w="20002">
+          <a:ln w="20002" cap="rnd">
             <a:solidFill>
               <a:srgbClr val="1359A0"/>
             </a:solidFill>
@@ -20030,7 +20030,7 @@
           <a:solidFill>
             <a:srgbClr val="1359A0"/>
           </a:solidFill>
-          <a:ln w="14288">
+          <a:ln w="14288" cap="rnd">
             <a:solidFill>
               <a:srgbClr val="1359A0"/>
             </a:solidFill>
@@ -20070,7 +20070,7 @@
             </a:pathLst>
           </a:custGeom>
           <a:noFill/>
-          <a:ln w="20002">
+          <a:ln w="20002" cap="rnd">
             <a:solidFill>
               <a:srgbClr val="FFFFFF"/>
             </a:solidFill>
@@ -20110,7 +20110,7 @@
             </a:pathLst>
           </a:custGeom>
           <a:noFill/>
-          <a:ln w="20002">
+          <a:ln w="20002" cap="rnd">
             <a:solidFill>
               <a:srgbClr val="FFFFFF"/>
             </a:solidFill>
@@ -20150,7 +20150,7 @@
             </a:pathLst>
           </a:custGeom>
           <a:noFill/>
-          <a:ln w="20002">
+          <a:ln w="20002" cap="rnd">
             <a:solidFill>
               <a:srgbClr val="FFFFFF"/>
             </a:solidFill>
@@ -20190,7 +20190,7 @@
             </a:pathLst>
           </a:custGeom>
           <a:noFill/>
-          <a:ln w="20002">
+          <a:ln w="20002" cap="rnd">
             <a:solidFill>
               <a:srgbClr val="FFFFFF"/>
             </a:solidFill>
@@ -20230,7 +20230,7 @@
             </a:pathLst>
           </a:custGeom>
           <a:noFill/>
-          <a:ln w="20002">
+          <a:ln w="20002" cap="rnd">
             <a:solidFill>
               <a:srgbClr val="FFFFFF"/>
             </a:solidFill>
@@ -20270,7 +20270,7 @@
             </a:pathLst>
           </a:custGeom>
           <a:noFill/>
-          <a:ln w="20002">
+          <a:ln w="20002" cap="rnd">
             <a:solidFill>
               <a:srgbClr val="FFFFFF"/>
             </a:solidFill>
@@ -20310,7 +20310,7 @@
             </a:pathLst>
           </a:custGeom>
           <a:noFill/>
-          <a:ln w="20002">
+          <a:ln w="20002" cap="rnd">
             <a:solidFill>
               <a:srgbClr val="FFFFFF"/>
             </a:solidFill>
@@ -20343,7 +20343,7 @@
           <a:solidFill>
             <a:srgbClr val="FFFFFF"/>
           </a:solidFill>
-          <a:ln w="20002">
+          <a:ln w="20002" cap="rnd">
             <a:solidFill>
               <a:srgbClr val="FFFFFF"/>
             </a:solidFill>
@@ -20376,7 +20376,7 @@
           <a:solidFill>
             <a:srgbClr val="FFFFFF"/>
           </a:solidFill>
-          <a:ln w="20002">
+          <a:ln w="20002" cap="rnd">
             <a:solidFill>
               <a:srgbClr val="FFFFFF"/>
             </a:solidFill>
@@ -20409,7 +20409,7 @@
           <a:solidFill>
             <a:srgbClr val="FFFFFF"/>
           </a:solidFill>
-          <a:ln w="20002">
+          <a:ln w="20002" cap="rnd">
             <a:solidFill>
               <a:srgbClr val="FFFFFF"/>
             </a:solidFill>
@@ -20442,7 +20442,7 @@
           <a:solidFill>
             <a:srgbClr val="FFFFFF"/>
           </a:solidFill>
-          <a:ln w="20002">
+          <a:ln w="20002" cap="rnd">
             <a:solidFill>
               <a:srgbClr val="FFFFFF"/>
             </a:solidFill>
@@ -20475,7 +20475,7 @@
           <a:solidFill>
             <a:srgbClr val="FFFFFF"/>
           </a:solidFill>
-          <a:ln w="20002">
+          <a:ln w="20002" cap="rnd">
             <a:solidFill>
               <a:srgbClr val="FFFFFF"/>
             </a:solidFill>
@@ -20672,7 +20672,7 @@
           <a:solidFill>
             <a:srgbClr val="1359A0"/>
           </a:solidFill>
-          <a:ln w="14288">
+          <a:ln w="14288" cap="rnd">
             <a:solidFill>
               <a:srgbClr val="1359A0"/>
             </a:solidFill>
@@ -20705,7 +20705,7 @@
           <a:solidFill>
             <a:srgbClr val="FFFFFF"/>
           </a:solidFill>
-          <a:ln w="20002">
+          <a:ln w="20002" cap="rnd">
             <a:solidFill>
               <a:srgbClr val="FFFFFF"/>
             </a:solidFill>
@@ -20745,7 +20745,7 @@
             </a:pathLst>
           </a:custGeom>
           <a:noFill/>
-          <a:ln w="20002">
+          <a:ln w="20002" cap="rnd">
             <a:solidFill>
               <a:srgbClr val="1359A0"/>
             </a:solidFill>
@@ -20785,7 +20785,7 @@
             </a:pathLst>
           </a:custGeom>
           <a:noFill/>
-          <a:ln w="20002">
+          <a:ln w="20002" cap="rnd">
             <a:solidFill>
               <a:srgbClr val="1359A0"/>
             </a:solidFill>
@@ -22358,7 +22358,7 @@
           <a:solidFill>
             <a:srgbClr val="1359A0"/>
           </a:solidFill>
-          <a:ln w="14288">
+          <a:ln w="14288" cap="rnd">
             <a:solidFill>
               <a:srgbClr val="1359A0"/>
             </a:solidFill>
@@ -27064,7 +27064,7 @@
           <a:solidFill>
             <a:srgbClr val="FFFFFF"/>
           </a:solidFill>
-          <a:ln w="11430">
+          <a:ln w="11430" cap="rnd">
             <a:solidFill>
               <a:srgbClr val="1359A0"/>
             </a:solidFill>
@@ -27099,7 +27099,7 @@
           <a:solidFill>
             <a:srgbClr val="1359A0"/>
           </a:solidFill>
-          <a:ln w="14288">
+          <a:ln w="14288" cap="rnd">
             <a:solidFill>
               <a:srgbClr val="1359A0"/>
             </a:solidFill>
@@ -27664,7 +27664,7 @@
           <a:solidFill>
             <a:srgbClr val="FFFFFF"/>
           </a:solidFill>
-          <a:ln w="11430">
+          <a:ln w="11430" cap="rnd">
             <a:solidFill>
               <a:srgbClr val="1359A0"/>
             </a:solidFill>
@@ -27699,7 +27699,7 @@
           <a:solidFill>
             <a:srgbClr val="1359A0"/>
           </a:solidFill>
-          <a:ln w="14288">
+          <a:ln w="14288" cap="rnd">
             <a:solidFill>
               <a:srgbClr val="1359A0"/>
             </a:solidFill>
@@ -28106,7 +28106,7 @@
           <a:solidFill>
             <a:srgbClr val="FFFFFF"/>
           </a:solidFill>
-          <a:ln w="11430">
+          <a:ln w="11430" cap="rnd">
             <a:solidFill>
               <a:srgbClr val="1359A0"/>
             </a:solidFill>
@@ -28141,7 +28141,7 @@
           <a:solidFill>
             <a:srgbClr val="1359A0"/>
           </a:solidFill>
-          <a:ln w="14288">
+          <a:ln w="14288" cap="rnd">
             <a:solidFill>
               <a:srgbClr val="1359A0"/>
             </a:solidFill>
@@ -29084,7 +29084,7 @@
           <a:solidFill>
             <a:srgbClr val="FFFFFF"/>
           </a:solidFill>
-          <a:ln w="11430">
+          <a:ln w="11430" cap="rnd">
             <a:solidFill>
               <a:srgbClr val="1359A0"/>
             </a:solidFill>
@@ -29119,7 +29119,7 @@
           <a:solidFill>
             <a:srgbClr val="1359A0"/>
           </a:solidFill>
-          <a:ln w="14288">
+          <a:ln w="14288" cap="rnd">
             <a:solidFill>
               <a:srgbClr val="1359A0"/>
             </a:solidFill>
@@ -30316,7 +30316,7 @@
           <a:solidFill>
             <a:srgbClr val="1359A0"/>
           </a:solidFill>
-          <a:ln w="14288">
+          <a:ln w="14288" cap="rnd">
             <a:solidFill>
               <a:srgbClr val="1359A0"/>
             </a:solidFill>

</xml_diff>